<commit_message>
Add presenter details to all decks and wire up college logo support
- Title slide: 'Presented by Lingesh K' with Register No. OSI2509030
- Footer of every content slide: name, register number, slide number
- Closing slide: full sign-off line with name, register number and course
- File properties (author/title/subject) set on all five decks
- Logo support: any image dropped in assets/ is picked up automatically and
  placed top-right on title, section, quote and closing slides, plus a small
  mark in the content-slide footer. Dark slides sit it on a white plate so any
  logo colour stays legible.
- Linter now also flags duplicate logos per slide
</commit_message>
<xml_diff>
--- a/Unit 1 - Introduction to AI and Gen AI.pptx
+++ b/Unit 1 - Introduction to AI and Gen AI.pptx
@@ -4304,7 +4304,7 @@
         </p:nvSpPr>
         <p:spPr>
           <a:xfrm>
-            <a:off x="932688" y="5159197"/>
+            <a:off x="932688" y="4992624"/>
             <a:ext cx="966784" cy="329184"/>
           </a:xfrm>
           <a:prstGeom prst="roundRect">
@@ -4371,7 +4371,7 @@
         </p:nvSpPr>
         <p:spPr>
           <a:xfrm>
-            <a:off x="2027488" y="5159197"/>
+            <a:off x="2027488" y="4992624"/>
             <a:ext cx="1298522" cy="329184"/>
           </a:xfrm>
           <a:prstGeom prst="roundRect">
@@ -4438,7 +4438,7 @@
         </p:nvSpPr>
         <p:spPr>
           <a:xfrm>
-            <a:off x="3454026" y="5159197"/>
+            <a:off x="3454026" y="4992624"/>
             <a:ext cx="1672081" cy="329184"/>
           </a:xfrm>
           <a:prstGeom prst="roundRect">
@@ -4505,7 +4505,7 @@
         </p:nvSpPr>
         <p:spPr>
           <a:xfrm>
-            <a:off x="5254123" y="5159197"/>
+            <a:off x="5254123" y="4992624"/>
             <a:ext cx="1301250" cy="329184"/>
           </a:xfrm>
           <a:prstGeom prst="roundRect">
@@ -4572,7 +4572,7 @@
         </p:nvSpPr>
         <p:spPr>
           <a:xfrm>
-            <a:off x="932688" y="5742432"/>
+            <a:off x="932688" y="5614416"/>
             <a:ext cx="3840480" cy="12700"/>
           </a:xfrm>
           <a:prstGeom prst="rect">
@@ -4616,8 +4616,8 @@
         </p:nvSpPr>
         <p:spPr>
           <a:xfrm>
-            <a:off x="932688" y="5925312"/>
-            <a:ext cx="5486400" cy="640080"/>
+            <a:off x="932688" y="5797296"/>
+            <a:ext cx="4937760" cy="640080"/>
           </a:xfrm>
           <a:prstGeom prst="rect">
             <a:avLst/>
@@ -4632,7 +4632,7 @@
           <a:p>
             <a:pPr algn="l">
               <a:lnSpc>
-                <a:spcPct val="130000"/>
+                <a:spcPct val="122000"/>
               </a:lnSpc>
               <a:spcBef>
                 <a:spcPts val="0"/>
@@ -4642,33 +4642,102 @@
               </a:spcAft>
             </a:pPr>
             <a:r>
-              <a:rPr sz="1050" b="1" i="0">
-                <a:solidFill>
-                  <a:srgbClr val="FFFFFF"/>
-                </a:solidFill>
-                <a:latin typeface="Segoe UI"/>
-                <a:ea typeface="Segoe UI"/>
-                <a:cs typeface="Segoe UI"/>
-              </a:rPr>
-              <a:t>PGPM · Systems Specialisation</a:t>
+              <a:rPr sz="850" b="1" i="0" spc="160">
+                <a:solidFill>
+                  <a:srgbClr val="00B3A4"/>
+                </a:solidFill>
+                <a:latin typeface="Segoe UI"/>
+                <a:ea typeface="Segoe UI"/>
+                <a:cs typeface="Segoe UI"/>
+              </a:rPr>
+              <a:t>PRESENTED BY</a:t>
             </a:r>
           </a:p>
           <a:p>
             <a:pPr algn="l">
               <a:lnSpc>
-                <a:spcPct val="130000"/>
+                <a:spcPct val="122000"/>
               </a:lnSpc>
               <a:spcBef>
-                <a:spcPts val="0"/>
+                <a:spcPts val="400"/>
               </a:spcBef>
               <a:spcAft>
                 <a:spcPts val="0"/>
               </a:spcAft>
             </a:pPr>
             <a:r>
+              <a:rPr sz="1300" b="1" i="0">
+                <a:solidFill>
+                  <a:srgbClr val="FFFFFF"/>
+                </a:solidFill>
+                <a:latin typeface="Segoe UI"/>
+                <a:ea typeface="Segoe UI"/>
+                <a:cs typeface="Segoe UI"/>
+              </a:rPr>
+              <a:t>Lingesh K</a:t>
+            </a:r>
+            <a:r>
               <a:rPr sz="1050" b="0" i="0">
                 <a:solidFill>
-                  <a:srgbClr val="8B9DBE"/>
+                  <a:srgbClr val="7E91B4"/>
+                </a:solidFill>
+                <a:latin typeface="Segoe UI"/>
+                <a:ea typeface="Segoe UI"/>
+                <a:cs typeface="Segoe UI"/>
+              </a:rPr>
+              <a:t>      Register No. </a:t>
+            </a:r>
+            <a:r>
+              <a:rPr sz="1050" b="1" i="0">
+                <a:solidFill>
+                  <a:srgbClr val="C5D2E8"/>
+                </a:solidFill>
+                <a:latin typeface="Segoe UI"/>
+                <a:ea typeface="Segoe UI"/>
+                <a:cs typeface="Segoe UI"/>
+              </a:rPr>
+              <a:t>OSI2509030</a:t>
+            </a:r>
+          </a:p>
+        </p:txBody>
+      </p:sp>
+      <p:sp>
+        <p:nvSpPr>
+          <p:cNvPr id="18" name="TextBox 17"/>
+          <p:cNvSpPr txBox="1"/>
+          <p:nvPr/>
+        </p:nvSpPr>
+        <p:spPr>
+          <a:xfrm>
+            <a:off x="7180783" y="5870448"/>
+            <a:ext cx="4206240" cy="640080"/>
+          </a:xfrm>
+          <a:prstGeom prst="rect">
+            <a:avLst/>
+          </a:prstGeom>
+          <a:noFill/>
+        </p:spPr>
+        <p:txBody>
+          <a:bodyPr wrap="square" lIns="0" rIns="0" tIns="0" bIns="0" anchor="t">
+            <a:spAutoFit/>
+          </a:bodyPr>
+          <a:lstStyle/>
+          <a:p>
+            <a:pPr algn="r">
+              <a:lnSpc>
+                <a:spcPct val="134000"/>
+              </a:lnSpc>
+              <a:spcBef>
+                <a:spcPts val="0"/>
+              </a:spcBef>
+              <a:spcAft>
+                <a:spcPts val="0"/>
+              </a:spcAft>
+            </a:pPr>
+            <a:r>
+              <a:rPr sz="1000" b="1" i="0">
+                <a:solidFill>
+                  <a:srgbClr val="C5D2E8"/>
                 </a:solidFill>
                 <a:latin typeface="Segoe UI"/>
                 <a:ea typeface="Segoe UI"/>
@@ -5079,7 +5148,7 @@
         <p:spPr>
           <a:xfrm>
             <a:off x="987552" y="5943600"/>
-            <a:ext cx="5486400" cy="274320"/>
+            <a:ext cx="6400800" cy="274320"/>
           </a:xfrm>
           <a:prstGeom prst="rect">
             <a:avLst/>
@@ -5188,7 +5257,7 @@
         <p:spPr>
           <a:xfrm>
             <a:off x="713232" y="6272784"/>
-            <a:ext cx="8073923" cy="219456"/>
+            <a:ext cx="5597920" cy="219456"/>
           </a:xfrm>
           <a:prstGeom prst="rect">
             <a:avLst/>
@@ -5256,8 +5325,8 @@
         </p:nvSpPr>
         <p:spPr>
           <a:xfrm>
-            <a:off x="10381183" y="6272784"/>
-            <a:ext cx="1097280" cy="219456"/>
+            <a:off x="8826703" y="6272784"/>
+            <a:ext cx="2651760" cy="219456"/>
           </a:xfrm>
           <a:prstGeom prst="rect">
             <a:avLst/>
@@ -5282,9 +5351,31 @@
               </a:spcAft>
             </a:pPr>
             <a:r>
+              <a:rPr sz="900" b="0" i="0">
+                <a:solidFill>
+                  <a:srgbClr val="636E85"/>
+                </a:solidFill>
+                <a:latin typeface="Segoe UI"/>
+                <a:ea typeface="Segoe UI"/>
+                <a:cs typeface="Segoe UI"/>
+              </a:rPr>
+              <a:t>Lingesh K  ·  OSI2509030</a:t>
+            </a:r>
+            <a:r>
+              <a:rPr sz="900" b="0" i="0">
+                <a:solidFill>
+                  <a:srgbClr val="141C2E"/>
+                </a:solidFill>
+                <a:latin typeface="Segoe UI"/>
+                <a:ea typeface="Segoe UI"/>
+                <a:cs typeface="Segoe UI"/>
+              </a:rPr>
+              <a:t>     </a:t>
+            </a:r>
+            <a:r>
               <a:rPr sz="900" b="1" i="0">
                 <a:solidFill>
-                  <a:srgbClr val="636E85"/>
+                  <a:srgbClr val="0E1E3C"/>
                 </a:solidFill>
                 <a:latin typeface="Segoe UI"/>
                 <a:ea typeface="Segoe UI"/>
@@ -6636,7 +6727,7 @@
         <p:spPr>
           <a:xfrm>
             <a:off x="713232" y="6272784"/>
-            <a:ext cx="8073923" cy="219456"/>
+            <a:ext cx="5597920" cy="219456"/>
           </a:xfrm>
           <a:prstGeom prst="rect">
             <a:avLst/>
@@ -6704,8 +6795,8 @@
         </p:nvSpPr>
         <p:spPr>
           <a:xfrm>
-            <a:off x="10381183" y="6272784"/>
-            <a:ext cx="1097280" cy="219456"/>
+            <a:off x="8826703" y="6272784"/>
+            <a:ext cx="2651760" cy="219456"/>
           </a:xfrm>
           <a:prstGeom prst="rect">
             <a:avLst/>
@@ -6730,9 +6821,31 @@
               </a:spcAft>
             </a:pPr>
             <a:r>
+              <a:rPr sz="900" b="0" i="0">
+                <a:solidFill>
+                  <a:srgbClr val="636E85"/>
+                </a:solidFill>
+                <a:latin typeface="Segoe UI"/>
+                <a:ea typeface="Segoe UI"/>
+                <a:cs typeface="Segoe UI"/>
+              </a:rPr>
+              <a:t>Lingesh K  ·  OSI2509030</a:t>
+            </a:r>
+            <a:r>
+              <a:rPr sz="900" b="0" i="0">
+                <a:solidFill>
+                  <a:srgbClr val="141C2E"/>
+                </a:solidFill>
+                <a:latin typeface="Segoe UI"/>
+                <a:ea typeface="Segoe UI"/>
+                <a:cs typeface="Segoe UI"/>
+              </a:rPr>
+              <a:t>     </a:t>
+            </a:r>
+            <a:r>
               <a:rPr sz="900" b="1" i="0">
                 <a:solidFill>
-                  <a:srgbClr val="636E85"/>
+                  <a:srgbClr val="0E1E3C"/>
                 </a:solidFill>
                 <a:latin typeface="Segoe UI"/>
                 <a:ea typeface="Segoe UI"/>
@@ -8096,7 +8209,7 @@
         <p:spPr>
           <a:xfrm>
             <a:off x="987552" y="5943600"/>
-            <a:ext cx="5486400" cy="274320"/>
+            <a:ext cx="6400800" cy="274320"/>
           </a:xfrm>
           <a:prstGeom prst="rect">
             <a:avLst/>
@@ -8205,7 +8318,7 @@
         <p:spPr>
           <a:xfrm>
             <a:off x="713232" y="6272784"/>
-            <a:ext cx="8073923" cy="219456"/>
+            <a:ext cx="5597920" cy="219456"/>
           </a:xfrm>
           <a:prstGeom prst="rect">
             <a:avLst/>
@@ -8273,8 +8386,8 @@
         </p:nvSpPr>
         <p:spPr>
           <a:xfrm>
-            <a:off x="10381183" y="6272784"/>
-            <a:ext cx="1097280" cy="219456"/>
+            <a:off x="8826703" y="6272784"/>
+            <a:ext cx="2651760" cy="219456"/>
           </a:xfrm>
           <a:prstGeom prst="rect">
             <a:avLst/>
@@ -8299,9 +8412,31 @@
               </a:spcAft>
             </a:pPr>
             <a:r>
+              <a:rPr sz="900" b="0" i="0">
+                <a:solidFill>
+                  <a:srgbClr val="636E85"/>
+                </a:solidFill>
+                <a:latin typeface="Segoe UI"/>
+                <a:ea typeface="Segoe UI"/>
+                <a:cs typeface="Segoe UI"/>
+              </a:rPr>
+              <a:t>Lingesh K  ·  OSI2509030</a:t>
+            </a:r>
+            <a:r>
+              <a:rPr sz="900" b="0" i="0">
+                <a:solidFill>
+                  <a:srgbClr val="141C2E"/>
+                </a:solidFill>
+                <a:latin typeface="Segoe UI"/>
+                <a:ea typeface="Segoe UI"/>
+                <a:cs typeface="Segoe UI"/>
+              </a:rPr>
+              <a:t>     </a:t>
+            </a:r>
+            <a:r>
               <a:rPr sz="900" b="1" i="0">
                 <a:solidFill>
-                  <a:srgbClr val="636E85"/>
+                  <a:srgbClr val="0E1E3C"/>
                 </a:solidFill>
                 <a:latin typeface="Segoe UI"/>
                 <a:ea typeface="Segoe UI"/>
@@ -10088,7 +10223,7 @@
         <p:spPr>
           <a:xfrm>
             <a:off x="713232" y="6272784"/>
-            <a:ext cx="8073923" cy="219456"/>
+            <a:ext cx="5597920" cy="219456"/>
           </a:xfrm>
           <a:prstGeom prst="rect">
             <a:avLst/>
@@ -10156,8 +10291,8 @@
         </p:nvSpPr>
         <p:spPr>
           <a:xfrm>
-            <a:off x="10381183" y="6272784"/>
-            <a:ext cx="1097280" cy="219456"/>
+            <a:off x="8826703" y="6272784"/>
+            <a:ext cx="2651760" cy="219456"/>
           </a:xfrm>
           <a:prstGeom prst="rect">
             <a:avLst/>
@@ -10182,9 +10317,31 @@
               </a:spcAft>
             </a:pPr>
             <a:r>
+              <a:rPr sz="900" b="0" i="0">
+                <a:solidFill>
+                  <a:srgbClr val="636E85"/>
+                </a:solidFill>
+                <a:latin typeface="Segoe UI"/>
+                <a:ea typeface="Segoe UI"/>
+                <a:cs typeface="Segoe UI"/>
+              </a:rPr>
+              <a:t>Lingesh K  ·  OSI2509030</a:t>
+            </a:r>
+            <a:r>
+              <a:rPr sz="900" b="0" i="0">
+                <a:solidFill>
+                  <a:srgbClr val="141C2E"/>
+                </a:solidFill>
+                <a:latin typeface="Segoe UI"/>
+                <a:ea typeface="Segoe UI"/>
+                <a:cs typeface="Segoe UI"/>
+              </a:rPr>
+              <a:t>     </a:t>
+            </a:r>
+            <a:r>
               <a:rPr sz="900" b="1" i="0">
                 <a:solidFill>
-                  <a:srgbClr val="636E85"/>
+                  <a:srgbClr val="0E1E3C"/>
                 </a:solidFill>
                 <a:latin typeface="Segoe UI"/>
                 <a:ea typeface="Segoe UI"/>
@@ -11727,7 +11884,7 @@
         <p:spPr>
           <a:xfrm>
             <a:off x="987552" y="5943600"/>
-            <a:ext cx="5486400" cy="274320"/>
+            <a:ext cx="6400800" cy="274320"/>
           </a:xfrm>
           <a:prstGeom prst="rect">
             <a:avLst/>
@@ -11836,7 +11993,7 @@
         <p:spPr>
           <a:xfrm>
             <a:off x="713232" y="6272784"/>
-            <a:ext cx="8073923" cy="219456"/>
+            <a:ext cx="5597920" cy="219456"/>
           </a:xfrm>
           <a:prstGeom prst="rect">
             <a:avLst/>
@@ -11904,8 +12061,8 @@
         </p:nvSpPr>
         <p:spPr>
           <a:xfrm>
-            <a:off x="10381183" y="6272784"/>
-            <a:ext cx="1097280" cy="219456"/>
+            <a:off x="8826703" y="6272784"/>
+            <a:ext cx="2651760" cy="219456"/>
           </a:xfrm>
           <a:prstGeom prst="rect">
             <a:avLst/>
@@ -11930,9 +12087,31 @@
               </a:spcAft>
             </a:pPr>
             <a:r>
+              <a:rPr sz="900" b="0" i="0">
+                <a:solidFill>
+                  <a:srgbClr val="636E85"/>
+                </a:solidFill>
+                <a:latin typeface="Segoe UI"/>
+                <a:ea typeface="Segoe UI"/>
+                <a:cs typeface="Segoe UI"/>
+              </a:rPr>
+              <a:t>Lingesh K  ·  OSI2509030</a:t>
+            </a:r>
+            <a:r>
+              <a:rPr sz="900" b="0" i="0">
+                <a:solidFill>
+                  <a:srgbClr val="141C2E"/>
+                </a:solidFill>
+                <a:latin typeface="Segoe UI"/>
+                <a:ea typeface="Segoe UI"/>
+                <a:cs typeface="Segoe UI"/>
+              </a:rPr>
+              <a:t>     </a:t>
+            </a:r>
+            <a:r>
               <a:rPr sz="900" b="1" i="0">
                 <a:solidFill>
-                  <a:srgbClr val="636E85"/>
+                  <a:srgbClr val="0E1E3C"/>
                 </a:solidFill>
                 <a:latin typeface="Segoe UI"/>
                 <a:ea typeface="Segoe UI"/>
@@ -13304,7 +13483,7 @@
         <p:spPr>
           <a:xfrm>
             <a:off x="713232" y="6272784"/>
-            <a:ext cx="8073923" cy="219456"/>
+            <a:ext cx="5597920" cy="219456"/>
           </a:xfrm>
           <a:prstGeom prst="rect">
             <a:avLst/>
@@ -13372,8 +13551,8 @@
         </p:nvSpPr>
         <p:spPr>
           <a:xfrm>
-            <a:off x="10381183" y="6272784"/>
-            <a:ext cx="1097280" cy="219456"/>
+            <a:off x="8826703" y="6272784"/>
+            <a:ext cx="2651760" cy="219456"/>
           </a:xfrm>
           <a:prstGeom prst="rect">
             <a:avLst/>
@@ -13398,9 +13577,31 @@
               </a:spcAft>
             </a:pPr>
             <a:r>
+              <a:rPr sz="900" b="0" i="0">
+                <a:solidFill>
+                  <a:srgbClr val="636E85"/>
+                </a:solidFill>
+                <a:latin typeface="Segoe UI"/>
+                <a:ea typeface="Segoe UI"/>
+                <a:cs typeface="Segoe UI"/>
+              </a:rPr>
+              <a:t>Lingesh K  ·  OSI2509030</a:t>
+            </a:r>
+            <a:r>
+              <a:rPr sz="900" b="0" i="0">
+                <a:solidFill>
+                  <a:srgbClr val="141C2E"/>
+                </a:solidFill>
+                <a:latin typeface="Segoe UI"/>
+                <a:ea typeface="Segoe UI"/>
+                <a:cs typeface="Segoe UI"/>
+              </a:rPr>
+              <a:t>     </a:t>
+            </a:r>
+            <a:r>
               <a:rPr sz="900" b="1" i="0">
                 <a:solidFill>
-                  <a:srgbClr val="636E85"/>
+                  <a:srgbClr val="0E1E3C"/>
                 </a:solidFill>
                 <a:latin typeface="Segoe UI"/>
                 <a:ea typeface="Segoe UI"/>
@@ -15363,7 +15564,7 @@
         <p:spPr>
           <a:xfrm>
             <a:off x="713232" y="6272784"/>
-            <a:ext cx="8073923" cy="219456"/>
+            <a:ext cx="5597920" cy="219456"/>
           </a:xfrm>
           <a:prstGeom prst="rect">
             <a:avLst/>
@@ -15431,8 +15632,8 @@
         </p:nvSpPr>
         <p:spPr>
           <a:xfrm>
-            <a:off x="10381183" y="6272784"/>
-            <a:ext cx="1097280" cy="219456"/>
+            <a:off x="8826703" y="6272784"/>
+            <a:ext cx="2651760" cy="219456"/>
           </a:xfrm>
           <a:prstGeom prst="rect">
             <a:avLst/>
@@ -15457,9 +15658,31 @@
               </a:spcAft>
             </a:pPr>
             <a:r>
+              <a:rPr sz="900" b="0" i="0">
+                <a:solidFill>
+                  <a:srgbClr val="636E85"/>
+                </a:solidFill>
+                <a:latin typeface="Segoe UI"/>
+                <a:ea typeface="Segoe UI"/>
+                <a:cs typeface="Segoe UI"/>
+              </a:rPr>
+              <a:t>Lingesh K  ·  OSI2509030</a:t>
+            </a:r>
+            <a:r>
+              <a:rPr sz="900" b="0" i="0">
+                <a:solidFill>
+                  <a:srgbClr val="141C2E"/>
+                </a:solidFill>
+                <a:latin typeface="Segoe UI"/>
+                <a:ea typeface="Segoe UI"/>
+                <a:cs typeface="Segoe UI"/>
+              </a:rPr>
+              <a:t>     </a:t>
+            </a:r>
+            <a:r>
               <a:rPr sz="900" b="1" i="0">
                 <a:solidFill>
-                  <a:srgbClr val="636E85"/>
+                  <a:srgbClr val="0E1E3C"/>
                 </a:solidFill>
                 <a:latin typeface="Segoe UI"/>
                 <a:ea typeface="Segoe UI"/>
@@ -16428,7 +16651,7 @@
         <p:spPr>
           <a:xfrm>
             <a:off x="713232" y="6272784"/>
-            <a:ext cx="8073923" cy="219456"/>
+            <a:ext cx="5597920" cy="219456"/>
           </a:xfrm>
           <a:prstGeom prst="rect">
             <a:avLst/>
@@ -16496,8 +16719,8 @@
         </p:nvSpPr>
         <p:spPr>
           <a:xfrm>
-            <a:off x="10381183" y="6272784"/>
-            <a:ext cx="1097280" cy="219456"/>
+            <a:off x="8826703" y="6272784"/>
+            <a:ext cx="2651760" cy="219456"/>
           </a:xfrm>
           <a:prstGeom prst="rect">
             <a:avLst/>
@@ -16522,9 +16745,31 @@
               </a:spcAft>
             </a:pPr>
             <a:r>
+              <a:rPr sz="900" b="0" i="0">
+                <a:solidFill>
+                  <a:srgbClr val="636E85"/>
+                </a:solidFill>
+                <a:latin typeface="Segoe UI"/>
+                <a:ea typeface="Segoe UI"/>
+                <a:cs typeface="Segoe UI"/>
+              </a:rPr>
+              <a:t>Lingesh K  ·  OSI2509030</a:t>
+            </a:r>
+            <a:r>
+              <a:rPr sz="900" b="0" i="0">
+                <a:solidFill>
+                  <a:srgbClr val="141C2E"/>
+                </a:solidFill>
+                <a:latin typeface="Segoe UI"/>
+                <a:ea typeface="Segoe UI"/>
+                <a:cs typeface="Segoe UI"/>
+              </a:rPr>
+              <a:t>     </a:t>
+            </a:r>
+            <a:r>
               <a:rPr sz="900" b="1" i="0">
                 <a:solidFill>
-                  <a:srgbClr val="636E85"/>
+                  <a:srgbClr val="0E1E3C"/>
                 </a:solidFill>
                 <a:latin typeface="Segoe UI"/>
                 <a:ea typeface="Segoe UI"/>
@@ -18087,7 +18332,7 @@
         <p:spPr>
           <a:xfrm>
             <a:off x="713232" y="6272784"/>
-            <a:ext cx="8073923" cy="219456"/>
+            <a:ext cx="5597920" cy="219456"/>
           </a:xfrm>
           <a:prstGeom prst="rect">
             <a:avLst/>
@@ -18155,8 +18400,8 @@
         </p:nvSpPr>
         <p:spPr>
           <a:xfrm>
-            <a:off x="10381183" y="6272784"/>
-            <a:ext cx="1097280" cy="219456"/>
+            <a:off x="8826703" y="6272784"/>
+            <a:ext cx="2651760" cy="219456"/>
           </a:xfrm>
           <a:prstGeom prst="rect">
             <a:avLst/>
@@ -18181,9 +18426,31 @@
               </a:spcAft>
             </a:pPr>
             <a:r>
+              <a:rPr sz="900" b="0" i="0">
+                <a:solidFill>
+                  <a:srgbClr val="636E85"/>
+                </a:solidFill>
+                <a:latin typeface="Segoe UI"/>
+                <a:ea typeface="Segoe UI"/>
+                <a:cs typeface="Segoe UI"/>
+              </a:rPr>
+              <a:t>Lingesh K  ·  OSI2509030</a:t>
+            </a:r>
+            <a:r>
+              <a:rPr sz="900" b="0" i="0">
+                <a:solidFill>
+                  <a:srgbClr val="141C2E"/>
+                </a:solidFill>
+                <a:latin typeface="Segoe UI"/>
+                <a:ea typeface="Segoe UI"/>
+                <a:cs typeface="Segoe UI"/>
+              </a:rPr>
+              <a:t>     </a:t>
+            </a:r>
+            <a:r>
               <a:rPr sz="900" b="1" i="0">
                 <a:solidFill>
-                  <a:srgbClr val="636E85"/>
+                  <a:srgbClr val="0E1E3C"/>
                 </a:solidFill>
                 <a:latin typeface="Segoe UI"/>
                 <a:ea typeface="Segoe UI"/>
@@ -19837,7 +20104,7 @@
         <p:spPr>
           <a:xfrm>
             <a:off x="713232" y="6272784"/>
-            <a:ext cx="8073923" cy="219456"/>
+            <a:ext cx="5597920" cy="219456"/>
           </a:xfrm>
           <a:prstGeom prst="rect">
             <a:avLst/>
@@ -19905,8 +20172,8 @@
         </p:nvSpPr>
         <p:spPr>
           <a:xfrm>
-            <a:off x="10381183" y="6272784"/>
-            <a:ext cx="1097280" cy="219456"/>
+            <a:off x="8826703" y="6272784"/>
+            <a:ext cx="2651760" cy="219456"/>
           </a:xfrm>
           <a:prstGeom prst="rect">
             <a:avLst/>
@@ -19931,9 +20198,31 @@
               </a:spcAft>
             </a:pPr>
             <a:r>
+              <a:rPr sz="900" b="0" i="0">
+                <a:solidFill>
+                  <a:srgbClr val="636E85"/>
+                </a:solidFill>
+                <a:latin typeface="Segoe UI"/>
+                <a:ea typeface="Segoe UI"/>
+                <a:cs typeface="Segoe UI"/>
+              </a:rPr>
+              <a:t>Lingesh K  ·  OSI2509030</a:t>
+            </a:r>
+            <a:r>
+              <a:rPr sz="900" b="0" i="0">
+                <a:solidFill>
+                  <a:srgbClr val="141C2E"/>
+                </a:solidFill>
+                <a:latin typeface="Segoe UI"/>
+                <a:ea typeface="Segoe UI"/>
+                <a:cs typeface="Segoe UI"/>
+              </a:rPr>
+              <a:t>     </a:t>
+            </a:r>
+            <a:r>
               <a:rPr sz="900" b="1" i="0">
                 <a:solidFill>
-                  <a:srgbClr val="636E85"/>
+                  <a:srgbClr val="0E1E3C"/>
                 </a:solidFill>
                 <a:latin typeface="Segoe UI"/>
                 <a:ea typeface="Segoe UI"/>
@@ -22088,8 +22377,8 @@
         </p:nvSpPr>
         <p:spPr>
           <a:xfrm>
-            <a:off x="987552" y="4882896"/>
-            <a:ext cx="7315200" cy="1572768"/>
+            <a:off x="987552" y="4718304"/>
+            <a:ext cx="7315200" cy="1207008"/>
           </a:xfrm>
           <a:prstGeom prst="rect">
             <a:avLst/>
@@ -22128,10 +22417,10 @@
           <a:p>
             <a:pPr algn="l">
               <a:lnSpc>
-                <a:spcPct val="132000"/>
+                <a:spcPct val="128000"/>
               </a:lnSpc>
               <a:spcBef>
-                <a:spcPts val="500"/>
+                <a:spcPts val="400"/>
               </a:spcBef>
               <a:spcAft>
                 <a:spcPts val="0"/>
@@ -22152,10 +22441,10 @@
           <a:p>
             <a:pPr algn="l">
               <a:lnSpc>
-                <a:spcPct val="132000"/>
+                <a:spcPct val="128000"/>
               </a:lnSpc>
               <a:spcBef>
-                <a:spcPts val="500"/>
+                <a:spcPts val="400"/>
               </a:spcBef>
               <a:spcAft>
                 <a:spcPts val="0"/>
@@ -22176,10 +22465,10 @@
           <a:p>
             <a:pPr algn="l">
               <a:lnSpc>
-                <a:spcPct val="132000"/>
+                <a:spcPct val="128000"/>
               </a:lnSpc>
               <a:spcBef>
-                <a:spcPts val="500"/>
+                <a:spcPts val="400"/>
               </a:spcBef>
               <a:spcAft>
                 <a:spcPts val="0"/>
@@ -22195,6 +22484,141 @@
                 <a:cs typeface="Segoe UI"/>
               </a:rPr>
               <a:t>— What should your team never paste into a public AI tool?</a:t>
+            </a:r>
+          </a:p>
+        </p:txBody>
+      </p:sp>
+      <p:sp>
+        <p:nvSpPr>
+          <p:cNvPr id="11" name="Rectangle 10"/>
+          <p:cNvSpPr/>
+          <p:nvPr/>
+        </p:nvSpPr>
+        <p:spPr>
+          <a:xfrm>
+            <a:off x="987552" y="6035040"/>
+            <a:ext cx="3291840" cy="12700"/>
+          </a:xfrm>
+          <a:prstGeom prst="rect">
+            <a:avLst/>
+          </a:prstGeom>
+          <a:solidFill>
+            <a:srgbClr val="2A3E66"/>
+          </a:solidFill>
+          <a:ln>
+            <a:noFill/>
+          </a:ln>
+          <a:effectLst/>
+        </p:spPr>
+        <p:style>
+          <a:lnRef idx="1">
+            <a:schemeClr val="accent1"/>
+          </a:lnRef>
+          <a:fillRef idx="3">
+            <a:schemeClr val="accent1"/>
+          </a:fillRef>
+          <a:effectRef idx="2">
+            <a:schemeClr val="accent1"/>
+          </a:effectRef>
+          <a:fontRef idx="minor">
+            <a:schemeClr val="lt1"/>
+          </a:fontRef>
+        </p:style>
+        <p:txBody>
+          <a:bodyPr rtlCol="0" anchor="ctr"/>
+          <a:lstStyle/>
+          <a:p>
+            <a:pPr algn="ctr"/>
+          </a:p>
+        </p:txBody>
+      </p:sp>
+      <p:sp>
+        <p:nvSpPr>
+          <p:cNvPr id="12" name="TextBox 11"/>
+          <p:cNvSpPr txBox="1"/>
+          <p:nvPr/>
+        </p:nvSpPr>
+        <p:spPr>
+          <a:xfrm>
+            <a:off x="987552" y="6163056"/>
+            <a:ext cx="5852160" cy="292608"/>
+          </a:xfrm>
+          <a:prstGeom prst="rect">
+            <a:avLst/>
+          </a:prstGeom>
+          <a:noFill/>
+        </p:spPr>
+        <p:txBody>
+          <a:bodyPr wrap="square" lIns="0" rIns="0" tIns="0" bIns="0" anchor="t">
+            <a:spAutoFit/>
+          </a:bodyPr>
+          <a:lstStyle/>
+          <a:p>
+            <a:pPr algn="l">
+              <a:lnSpc>
+                <a:spcPct val="122000"/>
+              </a:lnSpc>
+              <a:spcBef>
+                <a:spcPts val="0"/>
+              </a:spcBef>
+              <a:spcAft>
+                <a:spcPts val="0"/>
+              </a:spcAft>
+            </a:pPr>
+            <a:r>
+              <a:rPr sz="1150" b="1" i="0">
+                <a:solidFill>
+                  <a:srgbClr val="FFFFFF"/>
+                </a:solidFill>
+                <a:latin typeface="Segoe UI"/>
+                <a:ea typeface="Segoe UI"/>
+                <a:cs typeface="Segoe UI"/>
+              </a:rPr>
+              <a:t>Lingesh K</a:t>
+            </a:r>
+            <a:r>
+              <a:rPr sz="1000" b="0" i="0">
+                <a:solidFill>
+                  <a:srgbClr val="7E91B4"/>
+                </a:solidFill>
+                <a:latin typeface="Segoe UI"/>
+                <a:ea typeface="Segoe UI"/>
+                <a:cs typeface="Segoe UI"/>
+              </a:rPr>
+              <a:t>   ·   Register No. </a:t>
+            </a:r>
+            <a:r>
+              <a:rPr sz="1000" b="1" i="0">
+                <a:solidFill>
+                  <a:srgbClr val="C5D2E8"/>
+                </a:solidFill>
+                <a:latin typeface="Segoe UI"/>
+                <a:ea typeface="Segoe UI"/>
+                <a:cs typeface="Segoe UI"/>
+              </a:rPr>
+              <a:t>OSI2509030</a:t>
+            </a:r>
+            <a:r>
+              <a:rPr sz="1000" b="0" i="0">
+                <a:solidFill>
+                  <a:srgbClr val="4A5E86"/>
+                </a:solidFill>
+                <a:latin typeface="Segoe UI"/>
+                <a:ea typeface="Segoe UI"/>
+                <a:cs typeface="Segoe UI"/>
+              </a:rPr>
+              <a:t>   ·   </a:t>
+            </a:r>
+            <a:r>
+              <a:rPr sz="1000" b="0" i="0">
+                <a:solidFill>
+                  <a:srgbClr val="7E91B4"/>
+                </a:solidFill>
+                <a:latin typeface="Segoe UI"/>
+                <a:ea typeface="Segoe UI"/>
+                <a:cs typeface="Segoe UI"/>
+              </a:rPr>
+              <a:t>PGPM · Systems Specialisation</a:t>
             </a:r>
           </a:p>
         </p:txBody>
@@ -22599,7 +23023,7 @@
         <p:spPr>
           <a:xfrm>
             <a:off x="987552" y="5943600"/>
-            <a:ext cx="5486400" cy="274320"/>
+            <a:ext cx="6400800" cy="274320"/>
           </a:xfrm>
           <a:prstGeom prst="rect">
             <a:avLst/>
@@ -22708,7 +23132,7 @@
         <p:spPr>
           <a:xfrm>
             <a:off x="713232" y="6272784"/>
-            <a:ext cx="8073923" cy="219456"/>
+            <a:ext cx="5597920" cy="219456"/>
           </a:xfrm>
           <a:prstGeom prst="rect">
             <a:avLst/>
@@ -22776,8 +23200,8 @@
         </p:nvSpPr>
         <p:spPr>
           <a:xfrm>
-            <a:off x="10381183" y="6272784"/>
-            <a:ext cx="1097280" cy="219456"/>
+            <a:off x="8826703" y="6272784"/>
+            <a:ext cx="2651760" cy="219456"/>
           </a:xfrm>
           <a:prstGeom prst="rect">
             <a:avLst/>
@@ -22802,9 +23226,31 @@
               </a:spcAft>
             </a:pPr>
             <a:r>
+              <a:rPr sz="900" b="0" i="0">
+                <a:solidFill>
+                  <a:srgbClr val="636E85"/>
+                </a:solidFill>
+                <a:latin typeface="Segoe UI"/>
+                <a:ea typeface="Segoe UI"/>
+                <a:cs typeface="Segoe UI"/>
+              </a:rPr>
+              <a:t>Lingesh K  ·  OSI2509030</a:t>
+            </a:r>
+            <a:r>
+              <a:rPr sz="900" b="0" i="0">
+                <a:solidFill>
+                  <a:srgbClr val="141C2E"/>
+                </a:solidFill>
+                <a:latin typeface="Segoe UI"/>
+                <a:ea typeface="Segoe UI"/>
+                <a:cs typeface="Segoe UI"/>
+              </a:rPr>
+              <a:t>     </a:t>
+            </a:r>
+            <a:r>
               <a:rPr sz="900" b="1" i="0">
                 <a:solidFill>
-                  <a:srgbClr val="636E85"/>
+                  <a:srgbClr val="0E1E3C"/>
                 </a:solidFill>
                 <a:latin typeface="Segoe UI"/>
                 <a:ea typeface="Segoe UI"/>
@@ -24156,7 +24602,7 @@
         <p:spPr>
           <a:xfrm>
             <a:off x="713232" y="6272784"/>
-            <a:ext cx="8073923" cy="219456"/>
+            <a:ext cx="5597920" cy="219456"/>
           </a:xfrm>
           <a:prstGeom prst="rect">
             <a:avLst/>
@@ -24224,8 +24670,8 @@
         </p:nvSpPr>
         <p:spPr>
           <a:xfrm>
-            <a:off x="10381183" y="6272784"/>
-            <a:ext cx="1097280" cy="219456"/>
+            <a:off x="8826703" y="6272784"/>
+            <a:ext cx="2651760" cy="219456"/>
           </a:xfrm>
           <a:prstGeom prst="rect">
             <a:avLst/>
@@ -24250,9 +24696,31 @@
               </a:spcAft>
             </a:pPr>
             <a:r>
+              <a:rPr sz="900" b="0" i="0">
+                <a:solidFill>
+                  <a:srgbClr val="636E85"/>
+                </a:solidFill>
+                <a:latin typeface="Segoe UI"/>
+                <a:ea typeface="Segoe UI"/>
+                <a:cs typeface="Segoe UI"/>
+              </a:rPr>
+              <a:t>Lingesh K  ·  OSI2509030</a:t>
+            </a:r>
+            <a:r>
+              <a:rPr sz="900" b="0" i="0">
+                <a:solidFill>
+                  <a:srgbClr val="141C2E"/>
+                </a:solidFill>
+                <a:latin typeface="Segoe UI"/>
+                <a:ea typeface="Segoe UI"/>
+                <a:cs typeface="Segoe UI"/>
+              </a:rPr>
+              <a:t>     </a:t>
+            </a:r>
+            <a:r>
               <a:rPr sz="900" b="1" i="0">
                 <a:solidFill>
-                  <a:srgbClr val="636E85"/>
+                  <a:srgbClr val="0E1E3C"/>
                 </a:solidFill>
                 <a:latin typeface="Segoe UI"/>
                 <a:ea typeface="Segoe UI"/>
@@ -26000,7 +26468,7 @@
         <p:spPr>
           <a:xfrm>
             <a:off x="987552" y="5943600"/>
-            <a:ext cx="5486400" cy="274320"/>
+            <a:ext cx="6400800" cy="274320"/>
           </a:xfrm>
           <a:prstGeom prst="rect">
             <a:avLst/>
@@ -26109,7 +26577,7 @@
         <p:spPr>
           <a:xfrm>
             <a:off x="713232" y="6272784"/>
-            <a:ext cx="8073923" cy="219456"/>
+            <a:ext cx="5597920" cy="219456"/>
           </a:xfrm>
           <a:prstGeom prst="rect">
             <a:avLst/>
@@ -26177,8 +26645,8 @@
         </p:nvSpPr>
         <p:spPr>
           <a:xfrm>
-            <a:off x="10381183" y="6272784"/>
-            <a:ext cx="1097280" cy="219456"/>
+            <a:off x="8826703" y="6272784"/>
+            <a:ext cx="2651760" cy="219456"/>
           </a:xfrm>
           <a:prstGeom prst="rect">
             <a:avLst/>
@@ -26203,9 +26671,31 @@
               </a:spcAft>
             </a:pPr>
             <a:r>
+              <a:rPr sz="900" b="0" i="0">
+                <a:solidFill>
+                  <a:srgbClr val="636E85"/>
+                </a:solidFill>
+                <a:latin typeface="Segoe UI"/>
+                <a:ea typeface="Segoe UI"/>
+                <a:cs typeface="Segoe UI"/>
+              </a:rPr>
+              <a:t>Lingesh K  ·  OSI2509030</a:t>
+            </a:r>
+            <a:r>
+              <a:rPr sz="900" b="0" i="0">
+                <a:solidFill>
+                  <a:srgbClr val="141C2E"/>
+                </a:solidFill>
+                <a:latin typeface="Segoe UI"/>
+                <a:ea typeface="Segoe UI"/>
+                <a:cs typeface="Segoe UI"/>
+              </a:rPr>
+              <a:t>     </a:t>
+            </a:r>
+            <a:r>
               <a:rPr sz="900" b="1" i="0">
                 <a:solidFill>
-                  <a:srgbClr val="636E85"/>
+                  <a:srgbClr val="0E1E3C"/>
                 </a:solidFill>
                 <a:latin typeface="Segoe UI"/>
                 <a:ea typeface="Segoe UI"/>
@@ -27369,7 +27859,7 @@
         <p:spPr>
           <a:xfrm>
             <a:off x="713232" y="6272784"/>
-            <a:ext cx="8073923" cy="219456"/>
+            <a:ext cx="5597920" cy="219456"/>
           </a:xfrm>
           <a:prstGeom prst="rect">
             <a:avLst/>
@@ -27437,8 +27927,8 @@
         </p:nvSpPr>
         <p:spPr>
           <a:xfrm>
-            <a:off x="10381183" y="6272784"/>
-            <a:ext cx="1097280" cy="219456"/>
+            <a:off x="8826703" y="6272784"/>
+            <a:ext cx="2651760" cy="219456"/>
           </a:xfrm>
           <a:prstGeom prst="rect">
             <a:avLst/>
@@ -27463,9 +27953,31 @@
               </a:spcAft>
             </a:pPr>
             <a:r>
+              <a:rPr sz="900" b="0" i="0">
+                <a:solidFill>
+                  <a:srgbClr val="636E85"/>
+                </a:solidFill>
+                <a:latin typeface="Segoe UI"/>
+                <a:ea typeface="Segoe UI"/>
+                <a:cs typeface="Segoe UI"/>
+              </a:rPr>
+              <a:t>Lingesh K  ·  OSI2509030</a:t>
+            </a:r>
+            <a:r>
+              <a:rPr sz="900" b="0" i="0">
+                <a:solidFill>
+                  <a:srgbClr val="141C2E"/>
+                </a:solidFill>
+                <a:latin typeface="Segoe UI"/>
+                <a:ea typeface="Segoe UI"/>
+                <a:cs typeface="Segoe UI"/>
+              </a:rPr>
+              <a:t>     </a:t>
+            </a:r>
+            <a:r>
               <a:rPr sz="900" b="1" i="0">
                 <a:solidFill>
-                  <a:srgbClr val="636E85"/>
+                  <a:srgbClr val="0E1E3C"/>
                 </a:solidFill>
                 <a:latin typeface="Segoe UI"/>
                 <a:ea typeface="Segoe UI"/>
@@ -28500,7 +29012,7 @@
         <p:spPr>
           <a:xfrm>
             <a:off x="713232" y="6272784"/>
-            <a:ext cx="8073923" cy="219456"/>
+            <a:ext cx="5597920" cy="219456"/>
           </a:xfrm>
           <a:prstGeom prst="rect">
             <a:avLst/>
@@ -28568,8 +29080,8 @@
         </p:nvSpPr>
         <p:spPr>
           <a:xfrm>
-            <a:off x="10381183" y="6272784"/>
-            <a:ext cx="1097280" cy="219456"/>
+            <a:off x="8826703" y="6272784"/>
+            <a:ext cx="2651760" cy="219456"/>
           </a:xfrm>
           <a:prstGeom prst="rect">
             <a:avLst/>
@@ -28594,9 +29106,31 @@
               </a:spcAft>
             </a:pPr>
             <a:r>
+              <a:rPr sz="900" b="0" i="0">
+                <a:solidFill>
+                  <a:srgbClr val="636E85"/>
+                </a:solidFill>
+                <a:latin typeface="Segoe UI"/>
+                <a:ea typeface="Segoe UI"/>
+                <a:cs typeface="Segoe UI"/>
+              </a:rPr>
+              <a:t>Lingesh K  ·  OSI2509030</a:t>
+            </a:r>
+            <a:r>
+              <a:rPr sz="900" b="0" i="0">
+                <a:solidFill>
+                  <a:srgbClr val="141C2E"/>
+                </a:solidFill>
+                <a:latin typeface="Segoe UI"/>
+                <a:ea typeface="Segoe UI"/>
+                <a:cs typeface="Segoe UI"/>
+              </a:rPr>
+              <a:t>     </a:t>
+            </a:r>
+            <a:r>
               <a:rPr sz="900" b="1" i="0">
                 <a:solidFill>
-                  <a:srgbClr val="636E85"/>
+                  <a:srgbClr val="0E1E3C"/>
                 </a:solidFill>
                 <a:latin typeface="Segoe UI"/>
                 <a:ea typeface="Segoe UI"/>

</xml_diff>

<commit_message>
Remove the UNIT badge from opening slides and rebalance the title layout
The 'UNIT 01' pill is gone from all five title slides. With it removed the
title block was sitting low, so the title, rule, subtitle and chip row are now
centred as a group in the band between the logo and the presenter block. This
keeps one-line titles (Units 3 and 4) and two-line titles (Units 1, 2 and 5)
looking equally balanced, and fixes the chips crowding the subtitle.
</commit_message>
<xml_diff>
--- a/Unit 1 - Introduction to AI and Gen AI.pptx
+++ b/Unit 1 - Introduction to AI and Gen AI.pptx
@@ -4116,80 +4116,13 @@
       </p:pic>
       <p:sp>
         <p:nvSpPr>
-          <p:cNvPr id="9" name="Rounded Rectangle 8"/>
-          <p:cNvSpPr/>
-          <p:nvPr/>
-        </p:nvSpPr>
-        <p:spPr>
-          <a:xfrm>
-            <a:off x="932688" y="1572768"/>
-            <a:ext cx="1481328" cy="384048"/>
-          </a:xfrm>
-          <a:prstGeom prst="roundRect">
-            <a:avLst>
-              <a:gd name="adj" fmla="val 50000"/>
-            </a:avLst>
-          </a:prstGeom>
-          <a:noFill/>
-          <a:ln w="15875">
-            <a:solidFill>
-              <a:srgbClr val="3B7AF7"/>
-            </a:solidFill>
-          </a:ln>
-          <a:effectLst/>
-        </p:spPr>
-        <p:style>
-          <a:lnRef idx="1">
-            <a:schemeClr val="accent1"/>
-          </a:lnRef>
-          <a:fillRef idx="3">
-            <a:schemeClr val="accent1"/>
-          </a:fillRef>
-          <a:effectRef idx="2">
-            <a:schemeClr val="accent1"/>
-          </a:effectRef>
-          <a:fontRef idx="minor">
-            <a:schemeClr val="lt1"/>
-          </a:fontRef>
-        </p:style>
-        <p:txBody>
-          <a:bodyPr rtlCol="0" anchor="ctr" wrap="square"/>
-          <a:lstStyle/>
-          <a:p>
-            <a:pPr algn="ctr">
-              <a:lnSpc>
-                <a:spcPct val="122000"/>
-              </a:lnSpc>
-              <a:spcBef>
-                <a:spcPts val="0"/>
-              </a:spcBef>
-              <a:spcAft>
-                <a:spcPts val="0"/>
-              </a:spcAft>
-            </a:pPr>
-            <a:r>
-              <a:rPr sz="1050" b="1" i="0" spc="160">
-                <a:solidFill>
-                  <a:srgbClr val="FFFFFF"/>
-                </a:solidFill>
-                <a:latin typeface="Segoe UI"/>
-                <a:ea typeface="Segoe UI"/>
-                <a:cs typeface="Segoe UI"/>
-              </a:rPr>
-              <a:t>UNIT 01</a:t>
-            </a:r>
-          </a:p>
-        </p:txBody>
-      </p:sp>
-      <p:sp>
-        <p:nvSpPr>
-          <p:cNvPr id="10" name="TextBox 9"/>
+          <p:cNvPr id="9" name="TextBox 8"/>
           <p:cNvSpPr txBox="1"/>
           <p:nvPr/>
         </p:nvSpPr>
         <p:spPr>
           <a:xfrm>
-            <a:off x="932688" y="2304288"/>
+            <a:off x="932688" y="2065553"/>
             <a:ext cx="7406640" cy="1578807"/>
           </a:xfrm>
           <a:prstGeom prst="rect">
@@ -4230,13 +4163,13 @@
       </p:sp>
       <p:sp>
         <p:nvSpPr>
-          <p:cNvPr id="11" name="Rectangle 10"/>
+          <p:cNvPr id="10" name="Rectangle 9"/>
           <p:cNvSpPr/>
           <p:nvPr/>
         </p:nvSpPr>
         <p:spPr>
           <a:xfrm>
-            <a:off x="932688" y="3901383"/>
+            <a:off x="932688" y="3662648"/>
             <a:ext cx="658368" cy="45720"/>
           </a:xfrm>
           <a:prstGeom prst="rect">
@@ -4274,14 +4207,14 @@
       </p:sp>
       <p:sp>
         <p:nvSpPr>
-          <p:cNvPr id="12" name="TextBox 11"/>
+          <p:cNvPr id="11" name="TextBox 10"/>
           <p:cNvSpPr txBox="1"/>
           <p:nvPr/>
         </p:nvSpPr>
         <p:spPr>
           <a:xfrm>
-            <a:off x="932688" y="4212279"/>
-            <a:ext cx="6766560" cy="960120"/>
+            <a:off x="932688" y="3973544"/>
+            <a:ext cx="6766560" cy="745750"/>
           </a:xfrm>
           <a:prstGeom prst="rect">
             <a:avLst/>
@@ -4321,13 +4254,13 @@
       </p:sp>
       <p:sp>
         <p:nvSpPr>
-          <p:cNvPr id="13" name="Rounded Rectangle 12"/>
+          <p:cNvPr id="12" name="Rounded Rectangle 11"/>
           <p:cNvSpPr/>
           <p:nvPr/>
         </p:nvSpPr>
         <p:spPr>
           <a:xfrm>
-            <a:off x="932688" y="4992624"/>
+            <a:off x="932688" y="4993614"/>
             <a:ext cx="966784" cy="329184"/>
           </a:xfrm>
           <a:prstGeom prst="roundRect">
@@ -4388,13 +4321,13 @@
       </p:sp>
       <p:sp>
         <p:nvSpPr>
-          <p:cNvPr id="14" name="Rounded Rectangle 13"/>
+          <p:cNvPr id="13" name="Rounded Rectangle 12"/>
           <p:cNvSpPr/>
           <p:nvPr/>
         </p:nvSpPr>
         <p:spPr>
           <a:xfrm>
-            <a:off x="2027488" y="4992624"/>
+            <a:off x="2027488" y="4993614"/>
             <a:ext cx="1298522" cy="329184"/>
           </a:xfrm>
           <a:prstGeom prst="roundRect">
@@ -4455,13 +4388,13 @@
       </p:sp>
       <p:sp>
         <p:nvSpPr>
-          <p:cNvPr id="15" name="Rounded Rectangle 14"/>
+          <p:cNvPr id="14" name="Rounded Rectangle 13"/>
           <p:cNvSpPr/>
           <p:nvPr/>
         </p:nvSpPr>
         <p:spPr>
           <a:xfrm>
-            <a:off x="3454026" y="4992624"/>
+            <a:off x="3454026" y="4993614"/>
             <a:ext cx="1672081" cy="329184"/>
           </a:xfrm>
           <a:prstGeom prst="roundRect">
@@ -4522,13 +4455,13 @@
       </p:sp>
       <p:sp>
         <p:nvSpPr>
-          <p:cNvPr id="16" name="Rounded Rectangle 15"/>
+          <p:cNvPr id="15" name="Rounded Rectangle 14"/>
           <p:cNvSpPr/>
           <p:nvPr/>
         </p:nvSpPr>
         <p:spPr>
           <a:xfrm>
-            <a:off x="5254123" y="4992624"/>
+            <a:off x="5254123" y="4993614"/>
             <a:ext cx="1301250" cy="329184"/>
           </a:xfrm>
           <a:prstGeom prst="roundRect">
@@ -4589,7 +4522,7 @@
       </p:sp>
       <p:sp>
         <p:nvSpPr>
-          <p:cNvPr id="17" name="Rectangle 16"/>
+          <p:cNvPr id="16" name="Rectangle 15"/>
           <p:cNvSpPr/>
           <p:nvPr/>
         </p:nvSpPr>
@@ -4633,7 +4566,7 @@
       </p:sp>
       <p:sp>
         <p:nvSpPr>
-          <p:cNvPr id="18" name="TextBox 17"/>
+          <p:cNvPr id="17" name="TextBox 16"/>
           <p:cNvSpPr txBox="1"/>
           <p:nvPr/>
         </p:nvSpPr>

</xml_diff>